<commit_message>
tried to add QR code
</commit_message>
<xml_diff>
--- a/Four 2 Win.pptx
+++ b/Four 2 Win.pptx
@@ -7528,7 +7528,7 @@
         </p:nvSpPr>
         <p:spPr>
           <a:xfrm>
-            <a:off x="2117891" y="2644170"/>
+            <a:off x="2117891" y="215602"/>
             <a:ext cx="7956217" cy="1569660"/>
           </a:xfrm>
           <a:prstGeom prst="rect">
@@ -7545,6 +7545,77 @@
             <a:r>
               <a:rPr lang="en-US" sz="9600" dirty="0"/>
               <a:t>Any Questions?</a:t>
+            </a:r>
+          </a:p>
+        </p:txBody>
+      </p:sp>
+      <p:pic>
+        <p:nvPicPr>
+          <p:cNvPr id="3" name="Picture 2">
+            <a:extLst>
+              <a:ext uri="{FF2B5EF4-FFF2-40B4-BE49-F238E27FC236}">
+                <a16:creationId xmlns:a16="http://schemas.microsoft.com/office/drawing/2014/main" id="{E968EA9C-1C4D-73BF-D1AB-F9599223450B}"/>
+              </a:ext>
+            </a:extLst>
+          </p:cNvPr>
+          <p:cNvPicPr>
+            <a:picLocks noChangeAspect="1"/>
+          </p:cNvPicPr>
+          <p:nvPr/>
+        </p:nvPicPr>
+        <p:blipFill>
+          <a:blip r:embed="rId2">
+            <a:extLst>
+              <a:ext uri="{28A0092B-C50C-407E-A947-70E740481C1C}">
+                <a14:useLocalDpi xmlns:a14="http://schemas.microsoft.com/office/drawing/2010/main" val="0"/>
+              </a:ext>
+            </a:extLst>
+          </a:blip>
+          <a:stretch>
+            <a:fillRect/>
+          </a:stretch>
+        </p:blipFill>
+        <p:spPr>
+          <a:xfrm>
+            <a:off x="680884" y="2553929"/>
+            <a:ext cx="3124200" cy="3124200"/>
+          </a:xfrm>
+          <a:prstGeom prst="rect">
+            <a:avLst/>
+          </a:prstGeom>
+        </p:spPr>
+      </p:pic>
+      <p:sp>
+        <p:nvSpPr>
+          <p:cNvPr id="5" name="TextBox 4">
+            <a:extLst>
+              <a:ext uri="{FF2B5EF4-FFF2-40B4-BE49-F238E27FC236}">
+                <a16:creationId xmlns:a16="http://schemas.microsoft.com/office/drawing/2014/main" id="{B045A76A-9479-CDB9-05D2-E48C1657AAFA}"/>
+              </a:ext>
+            </a:extLst>
+          </p:cNvPr>
+          <p:cNvSpPr txBox="1"/>
+          <p:nvPr/>
+        </p:nvSpPr>
+        <p:spPr>
+          <a:xfrm>
+            <a:off x="680884" y="5354963"/>
+            <a:ext cx="3854246" cy="646331"/>
+          </a:xfrm>
+          <a:prstGeom prst="rect">
+            <a:avLst/>
+          </a:prstGeom>
+          <a:noFill/>
+        </p:spPr>
+        <p:txBody>
+          <a:bodyPr wrap="square" rtlCol="0">
+            <a:spAutoFit/>
+          </a:bodyPr>
+          <a:lstStyle/>
+          <a:p>
+            <a:r>
+              <a:rPr lang="en-US" sz="3600" dirty="0"/>
+              <a:t>Our public GitHub!</a:t>
             </a:r>
           </a:p>
         </p:txBody>

</xml_diff>

<commit_message>
Formatting + Bullet points
</commit_message>
<xml_diff>
--- a/Four 2 Win.pptx
+++ b/Four 2 Win.pptx
@@ -446,7 +446,7 @@
           <a:p>
             <a:fld id="{1A69082A-FE24-40AB-BD48-6844D502A070}" type="datetimeFigureOut">
               <a:rPr lang="en-US" smtClean="0"/>
-              <a:t>4/15/2026</a:t>
+              <a:t>4/18/2026</a:t>
             </a:fld>
             <a:endParaRPr lang="en-US"/>
           </a:p>
@@ -720,7 +720,7 @@
           <a:p>
             <a:fld id="{1A69082A-FE24-40AB-BD48-6844D502A070}" type="datetimeFigureOut">
               <a:rPr lang="en-US" smtClean="0"/>
-              <a:t>4/15/2026</a:t>
+              <a:t>4/18/2026</a:t>
             </a:fld>
             <a:endParaRPr lang="en-US"/>
           </a:p>
@@ -928,7 +928,7 @@
           <a:p>
             <a:fld id="{1A69082A-FE24-40AB-BD48-6844D502A070}" type="datetimeFigureOut">
               <a:rPr lang="en-US" smtClean="0"/>
-              <a:t>4/15/2026</a:t>
+              <a:t>4/18/2026</a:t>
             </a:fld>
             <a:endParaRPr lang="en-US"/>
           </a:p>
@@ -1148,7 +1148,7 @@
           <a:p>
             <a:fld id="{BC76F7AB-0E16-4C57-8F3A-5C240111FCB0}" type="datetimeFigureOut">
               <a:rPr lang="en-US" smtClean="0"/>
-              <a:t>4/15/2026</a:t>
+              <a:t>4/18/2026</a:t>
             </a:fld>
             <a:endParaRPr lang="en-US"/>
           </a:p>
@@ -1346,7 +1346,7 @@
           <a:p>
             <a:fld id="{BC76F7AB-0E16-4C57-8F3A-5C240111FCB0}" type="datetimeFigureOut">
               <a:rPr lang="en-US" smtClean="0"/>
-              <a:t>4/15/2026</a:t>
+              <a:t>4/18/2026</a:t>
             </a:fld>
             <a:endParaRPr lang="en-US"/>
           </a:p>
@@ -1621,7 +1621,7 @@
           <a:p>
             <a:fld id="{BC76F7AB-0E16-4C57-8F3A-5C240111FCB0}" type="datetimeFigureOut">
               <a:rPr lang="en-US" smtClean="0"/>
-              <a:t>4/15/2026</a:t>
+              <a:t>4/18/2026</a:t>
             </a:fld>
             <a:endParaRPr lang="en-US"/>
           </a:p>
@@ -1886,7 +1886,7 @@
           <a:p>
             <a:fld id="{BC76F7AB-0E16-4C57-8F3A-5C240111FCB0}" type="datetimeFigureOut">
               <a:rPr lang="en-US" smtClean="0"/>
-              <a:t>4/15/2026</a:t>
+              <a:t>4/18/2026</a:t>
             </a:fld>
             <a:endParaRPr lang="en-US"/>
           </a:p>
@@ -2298,7 +2298,7 @@
           <a:p>
             <a:fld id="{BC76F7AB-0E16-4C57-8F3A-5C240111FCB0}" type="datetimeFigureOut">
               <a:rPr lang="en-US" smtClean="0"/>
-              <a:t>4/15/2026</a:t>
+              <a:t>4/18/2026</a:t>
             </a:fld>
             <a:endParaRPr lang="en-US"/>
           </a:p>
@@ -2439,7 +2439,7 @@
           <a:p>
             <a:fld id="{BC76F7AB-0E16-4C57-8F3A-5C240111FCB0}" type="datetimeFigureOut">
               <a:rPr lang="en-US" smtClean="0"/>
-              <a:t>4/15/2026</a:t>
+              <a:t>4/18/2026</a:t>
             </a:fld>
             <a:endParaRPr lang="en-US"/>
           </a:p>
@@ -2552,7 +2552,7 @@
           <a:p>
             <a:fld id="{BC76F7AB-0E16-4C57-8F3A-5C240111FCB0}" type="datetimeFigureOut">
               <a:rPr lang="en-US" smtClean="0"/>
-              <a:t>4/15/2026</a:t>
+              <a:t>4/18/2026</a:t>
             </a:fld>
             <a:endParaRPr lang="en-US"/>
           </a:p>
@@ -2863,7 +2863,7 @@
           <a:p>
             <a:fld id="{BC76F7AB-0E16-4C57-8F3A-5C240111FCB0}" type="datetimeFigureOut">
               <a:rPr lang="en-US" smtClean="0"/>
-              <a:t>4/15/2026</a:t>
+              <a:t>4/18/2026</a:t>
             </a:fld>
             <a:endParaRPr lang="en-US"/>
           </a:p>
@@ -3061,7 +3061,7 @@
           <a:p>
             <a:fld id="{1A69082A-FE24-40AB-BD48-6844D502A070}" type="datetimeFigureOut">
               <a:rPr lang="en-US" smtClean="0"/>
-              <a:t>4/15/2026</a:t>
+              <a:t>4/18/2026</a:t>
             </a:fld>
             <a:endParaRPr lang="en-US"/>
           </a:p>
@@ -3349,7 +3349,7 @@
           <a:p>
             <a:fld id="{BC76F7AB-0E16-4C57-8F3A-5C240111FCB0}" type="datetimeFigureOut">
               <a:rPr lang="en-US" smtClean="0"/>
-              <a:t>4/15/2026</a:t>
+              <a:t>4/18/2026</a:t>
             </a:fld>
             <a:endParaRPr lang="en-US"/>
           </a:p>
@@ -3547,7 +3547,7 @@
           <a:p>
             <a:fld id="{BC76F7AB-0E16-4C57-8F3A-5C240111FCB0}" type="datetimeFigureOut">
               <a:rPr lang="en-US" smtClean="0"/>
-              <a:t>4/15/2026</a:t>
+              <a:t>4/18/2026</a:t>
             </a:fld>
             <a:endParaRPr lang="en-US"/>
           </a:p>
@@ -3755,7 +3755,7 @@
           <a:p>
             <a:fld id="{BC76F7AB-0E16-4C57-8F3A-5C240111FCB0}" type="datetimeFigureOut">
               <a:rPr lang="en-US" smtClean="0"/>
-              <a:t>4/15/2026</a:t>
+              <a:t>4/18/2026</a:t>
             </a:fld>
             <a:endParaRPr lang="en-US"/>
           </a:p>
@@ -4030,7 +4030,7 @@
           <a:p>
             <a:fld id="{1A69082A-FE24-40AB-BD48-6844D502A070}" type="datetimeFigureOut">
               <a:rPr lang="en-US" smtClean="0"/>
-              <a:t>4/15/2026</a:t>
+              <a:t>4/18/2026</a:t>
             </a:fld>
             <a:endParaRPr lang="en-US"/>
           </a:p>
@@ -4295,7 +4295,7 @@
           <a:p>
             <a:fld id="{1A69082A-FE24-40AB-BD48-6844D502A070}" type="datetimeFigureOut">
               <a:rPr lang="en-US" smtClean="0"/>
-              <a:t>4/15/2026</a:t>
+              <a:t>4/18/2026</a:t>
             </a:fld>
             <a:endParaRPr lang="en-US"/>
           </a:p>
@@ -4707,7 +4707,7 @@
           <a:p>
             <a:fld id="{1A69082A-FE24-40AB-BD48-6844D502A070}" type="datetimeFigureOut">
               <a:rPr lang="en-US" smtClean="0"/>
-              <a:t>4/15/2026</a:t>
+              <a:t>4/18/2026</a:t>
             </a:fld>
             <a:endParaRPr lang="en-US"/>
           </a:p>
@@ -4848,7 +4848,7 @@
           <a:p>
             <a:fld id="{1A69082A-FE24-40AB-BD48-6844D502A070}" type="datetimeFigureOut">
               <a:rPr lang="en-US" smtClean="0"/>
-              <a:t>4/15/2026</a:t>
+              <a:t>4/18/2026</a:t>
             </a:fld>
             <a:endParaRPr lang="en-US"/>
           </a:p>
@@ -4961,7 +4961,7 @@
           <a:p>
             <a:fld id="{1A69082A-FE24-40AB-BD48-6844D502A070}" type="datetimeFigureOut">
               <a:rPr lang="en-US" smtClean="0"/>
-              <a:t>4/15/2026</a:t>
+              <a:t>4/18/2026</a:t>
             </a:fld>
             <a:endParaRPr lang="en-US"/>
           </a:p>
@@ -5272,7 +5272,7 @@
           <a:p>
             <a:fld id="{1A69082A-FE24-40AB-BD48-6844D502A070}" type="datetimeFigureOut">
               <a:rPr lang="en-US" smtClean="0"/>
-              <a:t>4/15/2026</a:t>
+              <a:t>4/18/2026</a:t>
             </a:fld>
             <a:endParaRPr lang="en-US"/>
           </a:p>
@@ -5560,7 +5560,7 @@
           <a:p>
             <a:fld id="{1A69082A-FE24-40AB-BD48-6844D502A070}" type="datetimeFigureOut">
               <a:rPr lang="en-US" smtClean="0"/>
-              <a:t>4/15/2026</a:t>
+              <a:t>4/18/2026</a:t>
             </a:fld>
             <a:endParaRPr lang="en-US"/>
           </a:p>
@@ -5801,7 +5801,7 @@
           <a:p>
             <a:fld id="{1A69082A-FE24-40AB-BD48-6844D502A070}" type="datetimeFigureOut">
               <a:rPr lang="en-US" smtClean="0"/>
-              <a:t>4/15/2026</a:t>
+              <a:t>4/18/2026</a:t>
             </a:fld>
             <a:endParaRPr lang="en-US"/>
           </a:p>
@@ -6455,7 +6455,7 @@
           <a:p>
             <a:fld id="{BC76F7AB-0E16-4C57-8F3A-5C240111FCB0}" type="datetimeFigureOut">
               <a:rPr lang="en-US" smtClean="0"/>
-              <a:t>4/15/2026</a:t>
+              <a:t>4/18/2026</a:t>
             </a:fld>
             <a:endParaRPr lang="en-US"/>
           </a:p>
@@ -6953,6 +6953,42 @@
           </a:p>
         </p:txBody>
       </p:sp>
+      <p:sp>
+        <p:nvSpPr>
+          <p:cNvPr id="3" name="TextBox 2">
+            <a:extLst>
+              <a:ext uri="{FF2B5EF4-FFF2-40B4-BE49-F238E27FC236}">
+                <a16:creationId xmlns:a16="http://schemas.microsoft.com/office/drawing/2014/main" id="{C7E145AD-FF98-74C7-6586-56BF87C4F896}"/>
+              </a:ext>
+            </a:extLst>
+          </p:cNvPr>
+          <p:cNvSpPr txBox="1"/>
+          <p:nvPr/>
+        </p:nvSpPr>
+        <p:spPr>
+          <a:xfrm>
+            <a:off x="4544250" y="6107838"/>
+            <a:ext cx="2672179" cy="369332"/>
+          </a:xfrm>
+          <a:prstGeom prst="rect">
+            <a:avLst/>
+          </a:prstGeom>
+          <a:noFill/>
+        </p:spPr>
+        <p:txBody>
+          <a:bodyPr wrap="square" rtlCol="0">
+            <a:spAutoFit/>
+          </a:bodyPr>
+          <a:lstStyle/>
+          <a:p>
+            <a:pPr algn="ctr"/>
+            <a:r>
+              <a:rPr lang="en-US" dirty="0"/>
+              <a:t>CS 125 |Spring 2026</a:t>
+            </a:r>
+          </a:p>
+        </p:txBody>
+      </p:sp>
     </p:spTree>
     <p:extLst>
       <p:ext uri="{BB962C8B-B14F-4D97-AF65-F5344CB8AC3E}">
@@ -7034,25 +7070,76 @@
           <a:p>
             <a:r>
               <a:rPr lang="en-US" dirty="0"/>
-              <a:t>The project simulates a game of Connect 4.</a:t>
+              <a:t>The project simulates a game of Connect 4 using C language.</a:t>
             </a:r>
           </a:p>
           <a:p>
             <a:r>
               <a:rPr lang="en-US" dirty="0"/>
-              <a:t>The motivation was that we thought it would be simple to code. </a:t>
-            </a:r>
-          </a:p>
-          <a:p>
+              <a:t>Motivation:</a:t>
+            </a:r>
+          </a:p>
+          <a:p>
+            <a:pPr lvl="1"/>
             <a:r>
               <a:rPr lang="en-US" dirty="0"/>
-              <a:t>Used things like file I/O, arrays, structs, </a:t>
-            </a:r>
-            <a:r>
-              <a:rPr lang="en-US"/>
-              <a:t>and functions</a:t>
-            </a:r>
-            <a:endParaRPr lang="en-US" dirty="0"/>
+              <a:t>Applying learned skills to something fun</a:t>
+            </a:r>
+          </a:p>
+          <a:p>
+            <a:pPr lvl="1"/>
+            <a:r>
+              <a:rPr lang="en-US" dirty="0"/>
+              <a:t>Get more comfortable with C with a known topic</a:t>
+            </a:r>
+          </a:p>
+          <a:p>
+            <a:pPr lvl="1"/>
+            <a:r>
+              <a:rPr lang="en-US" dirty="0"/>
+              <a:t>Be able to share game/code with others</a:t>
+            </a:r>
+          </a:p>
+          <a:p>
+            <a:r>
+              <a:rPr lang="en-US" dirty="0"/>
+              <a:t>Used tools like file I/O, arrays, structs, and functions in the code</a:t>
+            </a:r>
+          </a:p>
+        </p:txBody>
+      </p:sp>
+      <p:sp>
+        <p:nvSpPr>
+          <p:cNvPr id="4" name="TextBox 3">
+            <a:extLst>
+              <a:ext uri="{FF2B5EF4-FFF2-40B4-BE49-F238E27FC236}">
+                <a16:creationId xmlns:a16="http://schemas.microsoft.com/office/drawing/2014/main" id="{70425729-CF5C-DD9C-E98D-CF4221F501BD}"/>
+              </a:ext>
+            </a:extLst>
+          </p:cNvPr>
+          <p:cNvSpPr txBox="1"/>
+          <p:nvPr/>
+        </p:nvSpPr>
+        <p:spPr>
+          <a:xfrm>
+            <a:off x="198783" y="6387548"/>
+            <a:ext cx="1086678" cy="369332"/>
+          </a:xfrm>
+          <a:prstGeom prst="rect">
+            <a:avLst/>
+          </a:prstGeom>
+          <a:noFill/>
+        </p:spPr>
+        <p:txBody>
+          <a:bodyPr wrap="square" rtlCol="0">
+            <a:spAutoFit/>
+          </a:bodyPr>
+          <a:lstStyle/>
+          <a:p>
+            <a:r>
+              <a:rPr lang="en-US" dirty="0"/>
+              <a:t>2</a:t>
+            </a:r>
           </a:p>
         </p:txBody>
       </p:sp>
@@ -7139,19 +7226,105 @@
           <a:p>
             <a:r>
               <a:rPr lang="en-US" dirty="0"/>
+              <a:t>Coding:</a:t>
+            </a:r>
+          </a:p>
+          <a:p>
+            <a:pPr lvl="1"/>
+            <a:r>
+              <a:rPr lang="en-US" dirty="0"/>
               <a:t>We had some trouble troubleshooting.</a:t>
             </a:r>
           </a:p>
           <a:p>
+            <a:pPr lvl="1"/>
             <a:r>
               <a:rPr lang="en-US" dirty="0"/>
               <a:t>Building 2D arrays is CHALLENGING!</a:t>
             </a:r>
           </a:p>
           <a:p>
+            <a:pPr lvl="1"/>
+            <a:r>
+              <a:rPr lang="en-US" dirty="0"/>
+              <a:t>TONS of functions =&gt; occasionally getting tangled, messy in main file</a:t>
+            </a:r>
+          </a:p>
+          <a:p>
+            <a:r>
+              <a:rPr lang="en-US" dirty="0"/>
+              <a:t>Team: </a:t>
+            </a:r>
+          </a:p>
+          <a:p>
+            <a:pPr lvl="1"/>
             <a:r>
               <a:rPr lang="en-US" dirty="0"/>
               <a:t>Some meetings had to be cancelled due to other commitments. </a:t>
+            </a:r>
+          </a:p>
+          <a:p>
+            <a:r>
+              <a:rPr lang="en-US" dirty="0"/>
+              <a:t>Solutions:</a:t>
+            </a:r>
+          </a:p>
+          <a:p>
+            <a:pPr lvl="1"/>
+            <a:r>
+              <a:rPr lang="en-US" dirty="0"/>
+              <a:t>Learned new topics/techniques not taught in class from websites like </a:t>
+            </a:r>
+            <a:r>
+              <a:rPr lang="en-US" dirty="0" err="1"/>
+              <a:t>StackExchange</a:t>
+            </a:r>
+            <a:endParaRPr lang="en-US" dirty="0"/>
+          </a:p>
+          <a:p>
+            <a:pPr lvl="1"/>
+            <a:r>
+              <a:rPr lang="en-US" dirty="0"/>
+              <a:t>Communication/Working with In-Class time</a:t>
+            </a:r>
+          </a:p>
+          <a:p>
+            <a:pPr lvl="1"/>
+            <a:endParaRPr lang="en-US" dirty="0"/>
+          </a:p>
+        </p:txBody>
+      </p:sp>
+      <p:sp>
+        <p:nvSpPr>
+          <p:cNvPr id="4" name="TextBox 3">
+            <a:extLst>
+              <a:ext uri="{FF2B5EF4-FFF2-40B4-BE49-F238E27FC236}">
+                <a16:creationId xmlns:a16="http://schemas.microsoft.com/office/drawing/2014/main" id="{78D362AE-6A34-4688-F610-B8E60F27346B}"/>
+              </a:ext>
+            </a:extLst>
+          </p:cNvPr>
+          <p:cNvSpPr txBox="1"/>
+          <p:nvPr/>
+        </p:nvSpPr>
+        <p:spPr>
+          <a:xfrm>
+            <a:off x="198783" y="6387548"/>
+            <a:ext cx="1086678" cy="369332"/>
+          </a:xfrm>
+          <a:prstGeom prst="rect">
+            <a:avLst/>
+          </a:prstGeom>
+          <a:noFill/>
+        </p:spPr>
+        <p:txBody>
+          <a:bodyPr wrap="square" rtlCol="0">
+            <a:spAutoFit/>
+          </a:bodyPr>
+          <a:lstStyle/>
+          <a:p>
+            <a:r>
+              <a:rPr lang="en-US" dirty="0"/>
+              <a:t>3</a:t>
             </a:r>
           </a:p>
         </p:txBody>
@@ -7243,13 +7416,48 @@
           <a:p>
             <a:r>
               <a:rPr lang="en-US" dirty="0"/>
-              <a:t>We also used AI for some troubleshooting but not all.</a:t>
+              <a:t>We also used AI for some troubleshooting/debugging, but not all.</a:t>
             </a:r>
           </a:p>
           <a:p>
             <a:r>
               <a:rPr lang="en-US" dirty="0"/>
               <a:t>We used it to help guide us to some ideas we had. </a:t>
+            </a:r>
+          </a:p>
+        </p:txBody>
+      </p:sp>
+      <p:sp>
+        <p:nvSpPr>
+          <p:cNvPr id="4" name="TextBox 3">
+            <a:extLst>
+              <a:ext uri="{FF2B5EF4-FFF2-40B4-BE49-F238E27FC236}">
+                <a16:creationId xmlns:a16="http://schemas.microsoft.com/office/drawing/2014/main" id="{46DA8C5F-DA7E-1595-F515-F7183EF13551}"/>
+              </a:ext>
+            </a:extLst>
+          </p:cNvPr>
+          <p:cNvSpPr txBox="1"/>
+          <p:nvPr/>
+        </p:nvSpPr>
+        <p:spPr>
+          <a:xfrm>
+            <a:off x="198783" y="6387548"/>
+            <a:ext cx="1086678" cy="369332"/>
+          </a:xfrm>
+          <a:prstGeom prst="rect">
+            <a:avLst/>
+          </a:prstGeom>
+          <a:noFill/>
+        </p:spPr>
+        <p:txBody>
+          <a:bodyPr wrap="square" rtlCol="0">
+            <a:spAutoFit/>
+          </a:bodyPr>
+          <a:lstStyle/>
+          <a:p>
+            <a:r>
+              <a:rPr lang="en-US" dirty="0"/>
+              <a:t>4</a:t>
             </a:r>
           </a:p>
         </p:txBody>
@@ -7386,6 +7594,41 @@
           </a:p>
         </p:txBody>
       </p:sp>
+      <p:sp>
+        <p:nvSpPr>
+          <p:cNvPr id="5" name="TextBox 4">
+            <a:extLst>
+              <a:ext uri="{FF2B5EF4-FFF2-40B4-BE49-F238E27FC236}">
+                <a16:creationId xmlns:a16="http://schemas.microsoft.com/office/drawing/2014/main" id="{DAA8DDC0-D67E-DD9C-B37C-EAA2722B1BAA}"/>
+              </a:ext>
+            </a:extLst>
+          </p:cNvPr>
+          <p:cNvSpPr txBox="1"/>
+          <p:nvPr/>
+        </p:nvSpPr>
+        <p:spPr>
+          <a:xfrm>
+            <a:off x="198783" y="6387548"/>
+            <a:ext cx="1086678" cy="369332"/>
+          </a:xfrm>
+          <a:prstGeom prst="rect">
+            <a:avLst/>
+          </a:prstGeom>
+          <a:noFill/>
+        </p:spPr>
+        <p:txBody>
+          <a:bodyPr wrap="square" rtlCol="0">
+            <a:spAutoFit/>
+          </a:bodyPr>
+          <a:lstStyle/>
+          <a:p>
+            <a:r>
+              <a:rPr lang="en-US" dirty="0"/>
+              <a:t>5</a:t>
+            </a:r>
+          </a:p>
+        </p:txBody>
+      </p:sp>
     </p:spTree>
     <p:extLst>
       <p:ext uri="{BB962C8B-B14F-4D97-AF65-F5344CB8AC3E}">
@@ -7473,14 +7716,94 @@
           <a:p>
             <a:r>
               <a:rPr lang="en-US" dirty="0"/>
+              <a:t>Learned new techniques and tools</a:t>
+            </a:r>
+          </a:p>
+          <a:p>
+            <a:r>
+              <a:rPr lang="en-US" dirty="0"/>
               <a:t>Worked through other commitments, schedules, and challenges</a:t>
             </a:r>
           </a:p>
           <a:p>
+            <a:r>
+              <a:rPr lang="en-US" dirty="0"/>
+              <a:t>Will likely use the project code to play with friends because why not?</a:t>
+            </a:r>
+          </a:p>
+          <a:p>
             <a:endParaRPr lang="en-US" dirty="0"/>
           </a:p>
           <a:p>
+            <a:r>
+              <a:rPr lang="en-US" dirty="0"/>
+              <a:t>Sources</a:t>
+            </a:r>
+          </a:p>
+          <a:p>
+            <a:pPr lvl="1"/>
+            <a:r>
+              <a:rPr lang="en-US" dirty="0">
+                <a:hlinkClick r:id="rId2"/>
+              </a:rPr>
+              <a:t>C - Stack Exchange</a:t>
+            </a:r>
             <a:endParaRPr lang="en-US" dirty="0"/>
+          </a:p>
+          <a:p>
+            <a:pPr lvl="1"/>
+            <a:r>
+              <a:rPr lang="en-US" dirty="0"/>
+              <a:t>Friends with coding knowledge</a:t>
+            </a:r>
+          </a:p>
+          <a:p>
+            <a:pPr lvl="1"/>
+            <a:r>
+              <a:rPr lang="en-US" dirty="0"/>
+              <a:t>Google Gemini</a:t>
+            </a:r>
+          </a:p>
+          <a:p>
+            <a:endParaRPr lang="en-US" dirty="0"/>
+          </a:p>
+          <a:p>
+            <a:endParaRPr lang="en-US" dirty="0"/>
+          </a:p>
+        </p:txBody>
+      </p:sp>
+      <p:sp>
+        <p:nvSpPr>
+          <p:cNvPr id="4" name="TextBox 3">
+            <a:extLst>
+              <a:ext uri="{FF2B5EF4-FFF2-40B4-BE49-F238E27FC236}">
+                <a16:creationId xmlns:a16="http://schemas.microsoft.com/office/drawing/2014/main" id="{FBDC0CFF-2F76-2320-B727-E9C0401DC35D}"/>
+              </a:ext>
+            </a:extLst>
+          </p:cNvPr>
+          <p:cNvSpPr txBox="1"/>
+          <p:nvPr/>
+        </p:nvSpPr>
+        <p:spPr>
+          <a:xfrm>
+            <a:off x="198783" y="6387548"/>
+            <a:ext cx="1086678" cy="369332"/>
+          </a:xfrm>
+          <a:prstGeom prst="rect">
+            <a:avLst/>
+          </a:prstGeom>
+          <a:noFill/>
+        </p:spPr>
+        <p:txBody>
+          <a:bodyPr wrap="square" rtlCol="0">
+            <a:spAutoFit/>
+          </a:bodyPr>
+          <a:lstStyle/>
+          <a:p>
+            <a:r>
+              <a:rPr lang="en-US" dirty="0"/>
+              <a:t>6</a:t>
+            </a:r>
           </a:p>
         </p:txBody>
       </p:sp>
@@ -7577,7 +7900,7 @@
         </p:blipFill>
         <p:spPr>
           <a:xfrm>
-            <a:off x="680884" y="2553929"/>
+            <a:off x="4168876" y="2336778"/>
             <a:ext cx="3124200" cy="3124200"/>
           </a:xfrm>
           <a:prstGeom prst="rect">
@@ -7599,7 +7922,7 @@
         </p:nvSpPr>
         <p:spPr>
           <a:xfrm>
-            <a:off x="680884" y="5354963"/>
+            <a:off x="3980675" y="5235693"/>
             <a:ext cx="3854246" cy="646331"/>
           </a:xfrm>
           <a:prstGeom prst="rect">
@@ -7616,6 +7939,77 @@
             <a:r>
               <a:rPr lang="en-US" sz="3600" dirty="0"/>
               <a:t>Our public GitHub!</a:t>
+            </a:r>
+          </a:p>
+        </p:txBody>
+      </p:sp>
+      <p:sp>
+        <p:nvSpPr>
+          <p:cNvPr id="2" name="TextBox 1">
+            <a:extLst>
+              <a:ext uri="{FF2B5EF4-FFF2-40B4-BE49-F238E27FC236}">
+                <a16:creationId xmlns:a16="http://schemas.microsoft.com/office/drawing/2014/main" id="{786F1AB6-EA06-525B-8090-6269C984440C}"/>
+              </a:ext>
+            </a:extLst>
+          </p:cNvPr>
+          <p:cNvSpPr txBox="1"/>
+          <p:nvPr/>
+        </p:nvSpPr>
+        <p:spPr>
+          <a:xfrm>
+            <a:off x="3980675" y="1785262"/>
+            <a:ext cx="3854246" cy="646331"/>
+          </a:xfrm>
+          <a:prstGeom prst="rect">
+            <a:avLst/>
+          </a:prstGeom>
+          <a:noFill/>
+        </p:spPr>
+        <p:txBody>
+          <a:bodyPr wrap="square" rtlCol="0">
+            <a:spAutoFit/>
+          </a:bodyPr>
+          <a:lstStyle/>
+          <a:p>
+            <a:pPr algn="ctr"/>
+            <a:r>
+              <a:rPr lang="en-US" sz="3600" dirty="0"/>
+              <a:t>Wanna try it out?</a:t>
+            </a:r>
+          </a:p>
+        </p:txBody>
+      </p:sp>
+      <p:sp>
+        <p:nvSpPr>
+          <p:cNvPr id="6" name="TextBox 5">
+            <a:extLst>
+              <a:ext uri="{FF2B5EF4-FFF2-40B4-BE49-F238E27FC236}">
+                <a16:creationId xmlns:a16="http://schemas.microsoft.com/office/drawing/2014/main" id="{F373B45D-D53B-6BC5-357D-9C55E46FB737}"/>
+              </a:ext>
+            </a:extLst>
+          </p:cNvPr>
+          <p:cNvSpPr txBox="1"/>
+          <p:nvPr/>
+        </p:nvSpPr>
+        <p:spPr>
+          <a:xfrm>
+            <a:off x="198783" y="6387548"/>
+            <a:ext cx="1086678" cy="369332"/>
+          </a:xfrm>
+          <a:prstGeom prst="rect">
+            <a:avLst/>
+          </a:prstGeom>
+          <a:noFill/>
+        </p:spPr>
+        <p:txBody>
+          <a:bodyPr wrap="square" rtlCol="0">
+            <a:spAutoFit/>
+          </a:bodyPr>
+          <a:lstStyle/>
+          <a:p>
+            <a:r>
+              <a:rPr lang="en-US" dirty="0"/>
+              <a:t>7</a:t>
             </a:r>
           </a:p>
         </p:txBody>

</xml_diff>